<commit_message>
Skeleton application event program
</commit_message>
<xml_diff>
--- a/Description/ResrvationNewLayout.pptx
+++ b/Description/ResrvationNewLayout.pptx
@@ -279,7 +279,7 @@
           <a:p>
             <a:fld id="{DDCE6D58-9B57-4731-A47B-3CD41B48F0A9}" type="datetimeFigureOut">
               <a:rPr lang="de-CH" smtClean="0"/>
-              <a:t>08.04.2026</a:t>
+              <a:t>16.04.2026</a:t>
             </a:fld>
             <a:endParaRPr lang="de-CH"/>
           </a:p>
@@ -449,7 +449,7 @@
           <a:p>
             <a:fld id="{DDCE6D58-9B57-4731-A47B-3CD41B48F0A9}" type="datetimeFigureOut">
               <a:rPr lang="de-CH" smtClean="0"/>
-              <a:t>08.04.2026</a:t>
+              <a:t>16.04.2026</a:t>
             </a:fld>
             <a:endParaRPr lang="de-CH"/>
           </a:p>
@@ -629,7 +629,7 @@
           <a:p>
             <a:fld id="{DDCE6D58-9B57-4731-A47B-3CD41B48F0A9}" type="datetimeFigureOut">
               <a:rPr lang="de-CH" smtClean="0"/>
-              <a:t>08.04.2026</a:t>
+              <a:t>16.04.2026</a:t>
             </a:fld>
             <a:endParaRPr lang="de-CH"/>
           </a:p>
@@ -799,7 +799,7 @@
           <a:p>
             <a:fld id="{DDCE6D58-9B57-4731-A47B-3CD41B48F0A9}" type="datetimeFigureOut">
               <a:rPr lang="de-CH" smtClean="0"/>
-              <a:t>08.04.2026</a:t>
+              <a:t>16.04.2026</a:t>
             </a:fld>
             <a:endParaRPr lang="de-CH"/>
           </a:p>
@@ -1045,7 +1045,7 @@
           <a:p>
             <a:fld id="{DDCE6D58-9B57-4731-A47B-3CD41B48F0A9}" type="datetimeFigureOut">
               <a:rPr lang="de-CH" smtClean="0"/>
-              <a:t>08.04.2026</a:t>
+              <a:t>16.04.2026</a:t>
             </a:fld>
             <a:endParaRPr lang="de-CH"/>
           </a:p>
@@ -1277,7 +1277,7 @@
           <a:p>
             <a:fld id="{DDCE6D58-9B57-4731-A47B-3CD41B48F0A9}" type="datetimeFigureOut">
               <a:rPr lang="de-CH" smtClean="0"/>
-              <a:t>08.04.2026</a:t>
+              <a:t>16.04.2026</a:t>
             </a:fld>
             <a:endParaRPr lang="de-CH"/>
           </a:p>
@@ -1644,7 +1644,7 @@
           <a:p>
             <a:fld id="{DDCE6D58-9B57-4731-A47B-3CD41B48F0A9}" type="datetimeFigureOut">
               <a:rPr lang="de-CH" smtClean="0"/>
-              <a:t>08.04.2026</a:t>
+              <a:t>16.04.2026</a:t>
             </a:fld>
             <a:endParaRPr lang="de-CH"/>
           </a:p>
@@ -1762,7 +1762,7 @@
           <a:p>
             <a:fld id="{DDCE6D58-9B57-4731-A47B-3CD41B48F0A9}" type="datetimeFigureOut">
               <a:rPr lang="de-CH" smtClean="0"/>
-              <a:t>08.04.2026</a:t>
+              <a:t>16.04.2026</a:t>
             </a:fld>
             <a:endParaRPr lang="de-CH"/>
           </a:p>
@@ -1857,7 +1857,7 @@
           <a:p>
             <a:fld id="{DDCE6D58-9B57-4731-A47B-3CD41B48F0A9}" type="datetimeFigureOut">
               <a:rPr lang="de-CH" smtClean="0"/>
-              <a:t>08.04.2026</a:t>
+              <a:t>16.04.2026</a:t>
             </a:fld>
             <a:endParaRPr lang="de-CH"/>
           </a:p>
@@ -2134,7 +2134,7 @@
           <a:p>
             <a:fld id="{DDCE6D58-9B57-4731-A47B-3CD41B48F0A9}" type="datetimeFigureOut">
               <a:rPr lang="de-CH" smtClean="0"/>
-              <a:t>08.04.2026</a:t>
+              <a:t>16.04.2026</a:t>
             </a:fld>
             <a:endParaRPr lang="de-CH"/>
           </a:p>
@@ -2387,7 +2387,7 @@
           <a:p>
             <a:fld id="{DDCE6D58-9B57-4731-A47B-3CD41B48F0A9}" type="datetimeFigureOut">
               <a:rPr lang="de-CH" smtClean="0"/>
-              <a:t>08.04.2026</a:t>
+              <a:t>16.04.2026</a:t>
             </a:fld>
             <a:endParaRPr lang="de-CH"/>
           </a:p>
@@ -2600,7 +2600,7 @@
           <a:p>
             <a:fld id="{DDCE6D58-9B57-4731-A47B-3CD41B48F0A9}" type="datetimeFigureOut">
               <a:rPr lang="de-CH" smtClean="0"/>
-              <a:t>08.04.2026</a:t>
+              <a:t>16.04.2026</a:t>
             </a:fld>
             <a:endParaRPr lang="de-CH"/>
           </a:p>
@@ -3019,8 +3019,8 @@
         </p:nvSpPr>
         <p:spPr>
           <a:xfrm>
-            <a:off x="512481" y="822337"/>
-            <a:ext cx="1794105" cy="523220"/>
+            <a:off x="3327951" y="470637"/>
+            <a:ext cx="1794105" cy="461665"/>
           </a:xfrm>
           <a:prstGeom prst="rect">
             <a:avLst/>
@@ -3035,7 +3035,7 @@
           <a:p>
             <a:pPr algn="ctr"/>
             <a:r>
-              <a:rPr lang="de-CH" sz="2800" b="1" dirty="0">
+              <a:rPr lang="de-CH" sz="2400" b="1" dirty="0">
                 <a:latin typeface="Arial Black" panose="020B0A04020102020204" pitchFamily="34" charset="0"/>
               </a:rPr>
               <a:t>Intranet</a:t>
@@ -3072,7 +3072,7 @@
         </p:blipFill>
         <p:spPr bwMode="auto">
           <a:xfrm>
-            <a:off x="707281" y="1345558"/>
+            <a:off x="3522751" y="932302"/>
             <a:ext cx="1451034" cy="1089888"/>
           </a:xfrm>
           <a:prstGeom prst="rect">
@@ -3090,12 +3090,207 @@
           </a:extLst>
         </p:spPr>
       </p:pic>
+      <p:sp>
+        <p:nvSpPr>
+          <p:cNvPr id="3" name="Rechteck: eine Ecke abgeschnitten 2">
+            <a:extLst>
+              <a:ext uri="{FF2B5EF4-FFF2-40B4-BE49-F238E27FC236}">
+                <a16:creationId xmlns:a16="http://schemas.microsoft.com/office/drawing/2014/main" id="{3D6A2AC0-443D-170A-283D-AECFDB8A6FD0}"/>
+              </a:ext>
+            </a:extLst>
+          </p:cNvPr>
+          <p:cNvSpPr/>
+          <p:nvPr/>
+        </p:nvSpPr>
+        <p:spPr>
+          <a:xfrm>
+            <a:off x="1433950" y="602669"/>
+            <a:ext cx="1069163" cy="1419521"/>
+          </a:xfrm>
+          <a:prstGeom prst="snip1Rect">
+            <a:avLst/>
+          </a:prstGeom>
+          <a:noFill/>
+          <a:ln>
+            <a:solidFill>
+              <a:schemeClr val="tx1"/>
+            </a:solidFill>
+          </a:ln>
+        </p:spPr>
+        <p:style>
+          <a:lnRef idx="2">
+            <a:schemeClr val="accent1">
+              <a:shade val="15000"/>
+            </a:schemeClr>
+          </a:lnRef>
+          <a:fillRef idx="1">
+            <a:schemeClr val="accent1"/>
+          </a:fillRef>
+          <a:effectRef idx="0">
+            <a:schemeClr val="accent1"/>
+          </a:effectRef>
+          <a:fontRef idx="minor">
+            <a:schemeClr val="lt1"/>
+          </a:fontRef>
+        </p:style>
+        <p:txBody>
+          <a:bodyPr rtlCol="0" anchor="ctr"/>
+          <a:lstStyle/>
+          <a:p>
+            <a:pPr algn="ctr"/>
+            <a:endParaRPr lang="de-CH" b="1" dirty="0">
+              <a:solidFill>
+                <a:schemeClr val="tx1"/>
+              </a:solidFill>
+              <a:latin typeface="Arial" panose="020B0604020202020204" pitchFamily="34" charset="0"/>
+              <a:cs typeface="Arial" panose="020B0604020202020204" pitchFamily="34" charset="0"/>
+            </a:endParaRPr>
+          </a:p>
+          <a:p>
+            <a:pPr algn="ctr"/>
+            <a:r>
+              <a:rPr lang="de-CH" b="1" dirty="0">
+                <a:solidFill>
+                  <a:schemeClr val="tx1"/>
+                </a:solidFill>
+                <a:latin typeface="Arial" panose="020B0604020202020204" pitchFamily="34" charset="0"/>
+                <a:cs typeface="Arial" panose="020B0604020202020204" pitchFamily="34" charset="0"/>
+              </a:rPr>
+              <a:t>Layout XML Datei</a:t>
+            </a:r>
+          </a:p>
+          <a:p>
+            <a:pPr algn="ctr"/>
+            <a:endParaRPr lang="de-CH" b="1" dirty="0">
+              <a:solidFill>
+                <a:schemeClr val="tx1"/>
+              </a:solidFill>
+              <a:latin typeface="Arial" panose="020B0604020202020204" pitchFamily="34" charset="0"/>
+              <a:cs typeface="Arial" panose="020B0604020202020204" pitchFamily="34" charset="0"/>
+            </a:endParaRPr>
+          </a:p>
+          <a:p>
+            <a:pPr algn="ctr"/>
+            <a:endParaRPr lang="de-CH" b="1" dirty="0">
+              <a:solidFill>
+                <a:schemeClr val="tx1"/>
+              </a:solidFill>
+              <a:latin typeface="Arial" panose="020B0604020202020204" pitchFamily="34" charset="0"/>
+              <a:cs typeface="Arial" panose="020B0604020202020204" pitchFamily="34" charset="0"/>
+            </a:endParaRPr>
+          </a:p>
+        </p:txBody>
+      </p:sp>
+      <p:sp>
+        <p:nvSpPr>
+          <p:cNvPr id="4" name="Pfeil: nach rechts 3">
+            <a:extLst>
+              <a:ext uri="{FF2B5EF4-FFF2-40B4-BE49-F238E27FC236}">
+                <a16:creationId xmlns:a16="http://schemas.microsoft.com/office/drawing/2014/main" id="{E63618D3-7625-E875-5354-769B8EBB1179}"/>
+              </a:ext>
+            </a:extLst>
+          </p:cNvPr>
+          <p:cNvSpPr/>
+          <p:nvPr/>
+        </p:nvSpPr>
+        <p:spPr>
+          <a:xfrm>
+            <a:off x="2739781" y="1204609"/>
+            <a:ext cx="623944" cy="365760"/>
+          </a:xfrm>
+          <a:prstGeom prst="rightArrow">
+            <a:avLst/>
+          </a:prstGeom>
+          <a:noFill/>
+          <a:ln w="28575">
+            <a:solidFill>
+              <a:schemeClr val="tx1"/>
+            </a:solidFill>
+          </a:ln>
+        </p:spPr>
+        <p:style>
+          <a:lnRef idx="2">
+            <a:schemeClr val="accent1">
+              <a:shade val="15000"/>
+            </a:schemeClr>
+          </a:lnRef>
+          <a:fillRef idx="1">
+            <a:schemeClr val="accent1"/>
+          </a:fillRef>
+          <a:effectRef idx="0">
+            <a:schemeClr val="accent1"/>
+          </a:effectRef>
+          <a:fontRef idx="minor">
+            <a:schemeClr val="lt1"/>
+          </a:fontRef>
+        </p:style>
+        <p:txBody>
+          <a:bodyPr rtlCol="0" anchor="ctr"/>
+          <a:lstStyle/>
+          <a:p>
+            <a:pPr algn="ctr"/>
+            <a:endParaRPr lang="de-CH"/>
+          </a:p>
+        </p:txBody>
+      </p:sp>
+      <p:sp>
+        <p:nvSpPr>
+          <p:cNvPr id="9" name="Pfeil: nach rechts 8">
+            <a:extLst>
+              <a:ext uri="{FF2B5EF4-FFF2-40B4-BE49-F238E27FC236}">
+                <a16:creationId xmlns:a16="http://schemas.microsoft.com/office/drawing/2014/main" id="{480CCF0E-2FDE-7E06-5542-D3E439FE72AD}"/>
+              </a:ext>
+            </a:extLst>
+          </p:cNvPr>
+          <p:cNvSpPr/>
+          <p:nvPr/>
+        </p:nvSpPr>
+        <p:spPr>
+          <a:xfrm>
+            <a:off x="5108436" y="1204609"/>
+            <a:ext cx="623944" cy="365760"/>
+          </a:xfrm>
+          <a:prstGeom prst="rightArrow">
+            <a:avLst/>
+          </a:prstGeom>
+          <a:noFill/>
+          <a:ln w="28575">
+            <a:solidFill>
+              <a:schemeClr val="tx1"/>
+            </a:solidFill>
+          </a:ln>
+        </p:spPr>
+        <p:style>
+          <a:lnRef idx="2">
+            <a:schemeClr val="accent1">
+              <a:shade val="15000"/>
+            </a:schemeClr>
+          </a:lnRef>
+          <a:fillRef idx="1">
+            <a:schemeClr val="accent1"/>
+          </a:fillRef>
+          <a:effectRef idx="0">
+            <a:schemeClr val="accent1"/>
+          </a:effectRef>
+          <a:fontRef idx="minor">
+            <a:schemeClr val="lt1"/>
+          </a:fontRef>
+        </p:style>
+        <p:txBody>
+          <a:bodyPr rtlCol="0" anchor="ctr"/>
+          <a:lstStyle/>
+          <a:p>
+            <a:pPr algn="ctr"/>
+            <a:endParaRPr lang="de-CH"/>
+          </a:p>
+        </p:txBody>
+      </p:sp>
       <p:pic>
         <p:nvPicPr>
-          <p:cNvPr id="5" name="Grafik 4">
-            <a:extLst>
-              <a:ext uri="{FF2B5EF4-FFF2-40B4-BE49-F238E27FC236}">
-                <a16:creationId xmlns:a16="http://schemas.microsoft.com/office/drawing/2014/main" id="{61481711-4F82-4C9B-86E3-2390ACD1C9A7}"/>
+          <p:cNvPr id="15" name="Grafik 14">
+            <a:extLst>
+              <a:ext uri="{FF2B5EF4-FFF2-40B4-BE49-F238E27FC236}">
+                <a16:creationId xmlns:a16="http://schemas.microsoft.com/office/drawing/2014/main" id="{A859E9C5-B61C-3491-0DB9-2B59D4EE00B9}"/>
               </a:ext>
             </a:extLst>
           </p:cNvPr>
@@ -3112,8 +3307,366 @@
         </p:blipFill>
         <p:spPr>
           <a:xfrm>
-            <a:off x="2549906" y="357636"/>
-            <a:ext cx="2037426" cy="3025098"/>
+            <a:off x="5946894" y="339316"/>
+            <a:ext cx="2043715" cy="2144108"/>
+          </a:xfrm>
+          <a:prstGeom prst="rect">
+            <a:avLst/>
+          </a:prstGeom>
+        </p:spPr>
+      </p:pic>
+      <p:sp>
+        <p:nvSpPr>
+          <p:cNvPr id="16" name="Pfeil: nach rechts 15">
+            <a:extLst>
+              <a:ext uri="{FF2B5EF4-FFF2-40B4-BE49-F238E27FC236}">
+                <a16:creationId xmlns:a16="http://schemas.microsoft.com/office/drawing/2014/main" id="{DE1E6BDE-0D3B-2B1B-A574-DFE72FA02B2A}"/>
+              </a:ext>
+            </a:extLst>
+          </p:cNvPr>
+          <p:cNvSpPr/>
+          <p:nvPr/>
+        </p:nvSpPr>
+        <p:spPr>
+          <a:xfrm>
+            <a:off x="1433950" y="3518933"/>
+            <a:ext cx="623944" cy="365760"/>
+          </a:xfrm>
+          <a:prstGeom prst="rightArrow">
+            <a:avLst/>
+          </a:prstGeom>
+          <a:noFill/>
+          <a:ln w="28575">
+            <a:solidFill>
+              <a:schemeClr val="tx1"/>
+            </a:solidFill>
+          </a:ln>
+        </p:spPr>
+        <p:style>
+          <a:lnRef idx="2">
+            <a:schemeClr val="accent1">
+              <a:shade val="15000"/>
+            </a:schemeClr>
+          </a:lnRef>
+          <a:fillRef idx="1">
+            <a:schemeClr val="accent1"/>
+          </a:fillRef>
+          <a:effectRef idx="0">
+            <a:schemeClr val="accent1"/>
+          </a:effectRef>
+          <a:fontRef idx="minor">
+            <a:schemeClr val="lt1"/>
+          </a:fontRef>
+        </p:style>
+        <p:txBody>
+          <a:bodyPr rtlCol="0" anchor="ctr"/>
+          <a:lstStyle/>
+          <a:p>
+            <a:pPr algn="ctr"/>
+            <a:endParaRPr lang="de-CH"/>
+          </a:p>
+        </p:txBody>
+      </p:sp>
+      <p:pic>
+        <p:nvPicPr>
+          <p:cNvPr id="24" name="Grafik 23">
+            <a:extLst>
+              <a:ext uri="{FF2B5EF4-FFF2-40B4-BE49-F238E27FC236}">
+                <a16:creationId xmlns:a16="http://schemas.microsoft.com/office/drawing/2014/main" id="{4222F74F-8BB1-23C9-C225-4B7D8D550919}"/>
+              </a:ext>
+            </a:extLst>
+          </p:cNvPr>
+          <p:cNvPicPr>
+            <a:picLocks noChangeAspect="1"/>
+          </p:cNvPicPr>
+          <p:nvPr/>
+        </p:nvPicPr>
+        <p:blipFill>
+          <a:blip r:embed="rId4"/>
+          <a:stretch>
+            <a:fillRect/>
+          </a:stretch>
+        </p:blipFill>
+        <p:spPr>
+          <a:xfrm>
+            <a:off x="5836916" y="2529802"/>
+            <a:ext cx="2263669" cy="2144109"/>
+          </a:xfrm>
+          <a:prstGeom prst="rect">
+            <a:avLst/>
+          </a:prstGeom>
+        </p:spPr>
+      </p:pic>
+      <p:pic>
+        <p:nvPicPr>
+          <p:cNvPr id="26" name="Grafik 25">
+            <a:extLst>
+              <a:ext uri="{FF2B5EF4-FFF2-40B4-BE49-F238E27FC236}">
+                <a16:creationId xmlns:a16="http://schemas.microsoft.com/office/drawing/2014/main" id="{CED8465B-4685-75F9-40F6-8E1FDD0D6B4E}"/>
+              </a:ext>
+            </a:extLst>
+          </p:cNvPr>
+          <p:cNvPicPr>
+            <a:picLocks noChangeAspect="1"/>
+          </p:cNvPicPr>
+          <p:nvPr/>
+        </p:nvPicPr>
+        <p:blipFill>
+          <a:blip r:embed="rId5"/>
+          <a:stretch>
+            <a:fillRect/>
+          </a:stretch>
+        </p:blipFill>
+        <p:spPr>
+          <a:xfrm>
+            <a:off x="2286673" y="2814931"/>
+            <a:ext cx="2154103" cy="1697852"/>
+          </a:xfrm>
+          <a:prstGeom prst="rect">
+            <a:avLst/>
+          </a:prstGeom>
+        </p:spPr>
+      </p:pic>
+      <p:sp>
+        <p:nvSpPr>
+          <p:cNvPr id="27" name="Pfeil: nach rechts 26">
+            <a:extLst>
+              <a:ext uri="{FF2B5EF4-FFF2-40B4-BE49-F238E27FC236}">
+                <a16:creationId xmlns:a16="http://schemas.microsoft.com/office/drawing/2014/main" id="{70486B96-89EB-ABE2-394C-7065D1E6F563}"/>
+              </a:ext>
+            </a:extLst>
+          </p:cNvPr>
+          <p:cNvSpPr/>
+          <p:nvPr/>
+        </p:nvSpPr>
+        <p:spPr>
+          <a:xfrm>
+            <a:off x="5108436" y="3518933"/>
+            <a:ext cx="623944" cy="365760"/>
+          </a:xfrm>
+          <a:prstGeom prst="rightArrow">
+            <a:avLst/>
+          </a:prstGeom>
+          <a:noFill/>
+          <a:ln w="28575">
+            <a:solidFill>
+              <a:schemeClr val="tx1"/>
+            </a:solidFill>
+          </a:ln>
+        </p:spPr>
+        <p:style>
+          <a:lnRef idx="2">
+            <a:schemeClr val="accent1">
+              <a:shade val="15000"/>
+            </a:schemeClr>
+          </a:lnRef>
+          <a:fillRef idx="1">
+            <a:schemeClr val="accent1"/>
+          </a:fillRef>
+          <a:effectRef idx="0">
+            <a:schemeClr val="accent1"/>
+          </a:effectRef>
+          <a:fontRef idx="minor">
+            <a:schemeClr val="lt1"/>
+          </a:fontRef>
+        </p:style>
+        <p:txBody>
+          <a:bodyPr rtlCol="0" anchor="ctr"/>
+          <a:lstStyle/>
+          <a:p>
+            <a:pPr algn="ctr"/>
+            <a:endParaRPr lang="de-CH"/>
+          </a:p>
+        </p:txBody>
+      </p:sp>
+      <p:pic>
+        <p:nvPicPr>
+          <p:cNvPr id="31" name="Grafik 30">
+            <a:extLst>
+              <a:ext uri="{FF2B5EF4-FFF2-40B4-BE49-F238E27FC236}">
+                <a16:creationId xmlns:a16="http://schemas.microsoft.com/office/drawing/2014/main" id="{47FD86A1-E985-C066-2FEA-B4B779C500E1}"/>
+              </a:ext>
+            </a:extLst>
+          </p:cNvPr>
+          <p:cNvPicPr>
+            <a:picLocks noChangeAspect="1"/>
+          </p:cNvPicPr>
+          <p:nvPr/>
+        </p:nvPicPr>
+        <p:blipFill>
+          <a:blip r:embed="rId6"/>
+          <a:stretch>
+            <a:fillRect/>
+          </a:stretch>
+        </p:blipFill>
+        <p:spPr>
+          <a:xfrm>
+            <a:off x="2286673" y="4782496"/>
+            <a:ext cx="2209848" cy="1741790"/>
+          </a:xfrm>
+          <a:prstGeom prst="rect">
+            <a:avLst/>
+          </a:prstGeom>
+        </p:spPr>
+      </p:pic>
+      <p:sp>
+        <p:nvSpPr>
+          <p:cNvPr id="32" name="Pfeil: nach rechts 31">
+            <a:extLst>
+              <a:ext uri="{FF2B5EF4-FFF2-40B4-BE49-F238E27FC236}">
+                <a16:creationId xmlns:a16="http://schemas.microsoft.com/office/drawing/2014/main" id="{508059D0-DBD9-CD0F-458A-0290073AFF3C}"/>
+              </a:ext>
+            </a:extLst>
+          </p:cNvPr>
+          <p:cNvSpPr/>
+          <p:nvPr/>
+        </p:nvSpPr>
+        <p:spPr>
+          <a:xfrm>
+            <a:off x="1475763" y="5470511"/>
+            <a:ext cx="623944" cy="365760"/>
+          </a:xfrm>
+          <a:prstGeom prst="rightArrow">
+            <a:avLst/>
+          </a:prstGeom>
+          <a:noFill/>
+          <a:ln w="28575">
+            <a:solidFill>
+              <a:schemeClr val="tx1"/>
+            </a:solidFill>
+          </a:ln>
+        </p:spPr>
+        <p:style>
+          <a:lnRef idx="2">
+            <a:schemeClr val="accent1">
+              <a:shade val="15000"/>
+            </a:schemeClr>
+          </a:lnRef>
+          <a:fillRef idx="1">
+            <a:schemeClr val="accent1"/>
+          </a:fillRef>
+          <a:effectRef idx="0">
+            <a:schemeClr val="accent1"/>
+          </a:effectRef>
+          <a:fontRef idx="minor">
+            <a:schemeClr val="lt1"/>
+          </a:fontRef>
+        </p:style>
+        <p:txBody>
+          <a:bodyPr rtlCol="0" anchor="ctr"/>
+          <a:lstStyle/>
+          <a:p>
+            <a:pPr algn="ctr"/>
+            <a:endParaRPr lang="de-CH"/>
+          </a:p>
+        </p:txBody>
+      </p:sp>
+      <p:sp>
+        <p:nvSpPr>
+          <p:cNvPr id="35" name="Pfeil: nach rechts 34">
+            <a:extLst>
+              <a:ext uri="{FF2B5EF4-FFF2-40B4-BE49-F238E27FC236}">
+                <a16:creationId xmlns:a16="http://schemas.microsoft.com/office/drawing/2014/main" id="{E3622591-324C-8565-8509-79D0977A44A3}"/>
+              </a:ext>
+            </a:extLst>
+          </p:cNvPr>
+          <p:cNvSpPr/>
+          <p:nvPr/>
+        </p:nvSpPr>
+        <p:spPr>
+          <a:xfrm>
+            <a:off x="5185524" y="5387970"/>
+            <a:ext cx="623944" cy="365760"/>
+          </a:xfrm>
+          <a:prstGeom prst="rightArrow">
+            <a:avLst/>
+          </a:prstGeom>
+          <a:noFill/>
+          <a:ln w="28575">
+            <a:solidFill>
+              <a:schemeClr val="tx1"/>
+            </a:solidFill>
+          </a:ln>
+        </p:spPr>
+        <p:style>
+          <a:lnRef idx="2">
+            <a:schemeClr val="accent1">
+              <a:shade val="15000"/>
+            </a:schemeClr>
+          </a:lnRef>
+          <a:fillRef idx="1">
+            <a:schemeClr val="accent1"/>
+          </a:fillRef>
+          <a:effectRef idx="0">
+            <a:schemeClr val="accent1"/>
+          </a:effectRef>
+          <a:fontRef idx="minor">
+            <a:schemeClr val="lt1"/>
+          </a:fontRef>
+        </p:style>
+        <p:txBody>
+          <a:bodyPr rtlCol="0" anchor="ctr"/>
+          <a:lstStyle/>
+          <a:p>
+            <a:pPr algn="ctr"/>
+            <a:endParaRPr lang="de-CH"/>
+          </a:p>
+        </p:txBody>
+      </p:sp>
+      <p:pic>
+        <p:nvPicPr>
+          <p:cNvPr id="37" name="Grafik 36">
+            <a:extLst>
+              <a:ext uri="{FF2B5EF4-FFF2-40B4-BE49-F238E27FC236}">
+                <a16:creationId xmlns:a16="http://schemas.microsoft.com/office/drawing/2014/main" id="{47F77300-43CE-FA5B-A117-F828858A0544}"/>
+              </a:ext>
+            </a:extLst>
+          </p:cNvPr>
+          <p:cNvPicPr>
+            <a:picLocks noChangeAspect="1"/>
+          </p:cNvPicPr>
+          <p:nvPr/>
+        </p:nvPicPr>
+        <p:blipFill>
+          <a:blip r:embed="rId7"/>
+          <a:stretch>
+            <a:fillRect/>
+          </a:stretch>
+        </p:blipFill>
+        <p:spPr>
+          <a:xfrm>
+            <a:off x="5955531" y="4838714"/>
+            <a:ext cx="892078" cy="1701990"/>
+          </a:xfrm>
+          <a:prstGeom prst="rect">
+            <a:avLst/>
+          </a:prstGeom>
+        </p:spPr>
+      </p:pic>
+      <p:pic>
+        <p:nvPicPr>
+          <p:cNvPr id="39" name="Grafik 38">
+            <a:extLst>
+              <a:ext uri="{FF2B5EF4-FFF2-40B4-BE49-F238E27FC236}">
+                <a16:creationId xmlns:a16="http://schemas.microsoft.com/office/drawing/2014/main" id="{2AFCC7E1-DC5E-D9CF-D417-6494C4C5C88F}"/>
+              </a:ext>
+            </a:extLst>
+          </p:cNvPr>
+          <p:cNvPicPr>
+            <a:picLocks noChangeAspect="1"/>
+          </p:cNvPicPr>
+          <p:nvPr/>
+        </p:nvPicPr>
+        <p:blipFill>
+          <a:blip r:embed="rId8"/>
+          <a:stretch>
+            <a:fillRect/>
+          </a:stretch>
+        </p:blipFill>
+        <p:spPr>
+          <a:xfrm>
+            <a:off x="7014454" y="4993469"/>
+            <a:ext cx="1141481" cy="1520522"/>
           </a:xfrm>
           <a:prstGeom prst="rect">
             <a:avLst/>

</xml_diff>

<commit_message>
GUI changes and help links added
</commit_message>
<xml_diff>
--- a/Description/ResrvationNewLayout.pptx
+++ b/Description/ResrvationNewLayout.pptx
@@ -279,7 +279,7 @@
           <a:p>
             <a:fld id="{DDCE6D58-9B57-4731-A47B-3CD41B48F0A9}" type="datetimeFigureOut">
               <a:rPr lang="de-CH" smtClean="0"/>
-              <a:t>16.04.2026</a:t>
+              <a:t>13.05.2026</a:t>
             </a:fld>
             <a:endParaRPr lang="de-CH"/>
           </a:p>
@@ -449,7 +449,7 @@
           <a:p>
             <a:fld id="{DDCE6D58-9B57-4731-A47B-3CD41B48F0A9}" type="datetimeFigureOut">
               <a:rPr lang="de-CH" smtClean="0"/>
-              <a:t>16.04.2026</a:t>
+              <a:t>13.05.2026</a:t>
             </a:fld>
             <a:endParaRPr lang="de-CH"/>
           </a:p>
@@ -629,7 +629,7 @@
           <a:p>
             <a:fld id="{DDCE6D58-9B57-4731-A47B-3CD41B48F0A9}" type="datetimeFigureOut">
               <a:rPr lang="de-CH" smtClean="0"/>
-              <a:t>16.04.2026</a:t>
+              <a:t>13.05.2026</a:t>
             </a:fld>
             <a:endParaRPr lang="de-CH"/>
           </a:p>
@@ -799,7 +799,7 @@
           <a:p>
             <a:fld id="{DDCE6D58-9B57-4731-A47B-3CD41B48F0A9}" type="datetimeFigureOut">
               <a:rPr lang="de-CH" smtClean="0"/>
-              <a:t>16.04.2026</a:t>
+              <a:t>13.05.2026</a:t>
             </a:fld>
             <a:endParaRPr lang="de-CH"/>
           </a:p>
@@ -1045,7 +1045,7 @@
           <a:p>
             <a:fld id="{DDCE6D58-9B57-4731-A47B-3CD41B48F0A9}" type="datetimeFigureOut">
               <a:rPr lang="de-CH" smtClean="0"/>
-              <a:t>16.04.2026</a:t>
+              <a:t>13.05.2026</a:t>
             </a:fld>
             <a:endParaRPr lang="de-CH"/>
           </a:p>
@@ -1277,7 +1277,7 @@
           <a:p>
             <a:fld id="{DDCE6D58-9B57-4731-A47B-3CD41B48F0A9}" type="datetimeFigureOut">
               <a:rPr lang="de-CH" smtClean="0"/>
-              <a:t>16.04.2026</a:t>
+              <a:t>13.05.2026</a:t>
             </a:fld>
             <a:endParaRPr lang="de-CH"/>
           </a:p>
@@ -1644,7 +1644,7 @@
           <a:p>
             <a:fld id="{DDCE6D58-9B57-4731-A47B-3CD41B48F0A9}" type="datetimeFigureOut">
               <a:rPr lang="de-CH" smtClean="0"/>
-              <a:t>16.04.2026</a:t>
+              <a:t>13.05.2026</a:t>
             </a:fld>
             <a:endParaRPr lang="de-CH"/>
           </a:p>
@@ -1762,7 +1762,7 @@
           <a:p>
             <a:fld id="{DDCE6D58-9B57-4731-A47B-3CD41B48F0A9}" type="datetimeFigureOut">
               <a:rPr lang="de-CH" smtClean="0"/>
-              <a:t>16.04.2026</a:t>
+              <a:t>13.05.2026</a:t>
             </a:fld>
             <a:endParaRPr lang="de-CH"/>
           </a:p>
@@ -1857,7 +1857,7 @@
           <a:p>
             <a:fld id="{DDCE6D58-9B57-4731-A47B-3CD41B48F0A9}" type="datetimeFigureOut">
               <a:rPr lang="de-CH" smtClean="0"/>
-              <a:t>16.04.2026</a:t>
+              <a:t>13.05.2026</a:t>
             </a:fld>
             <a:endParaRPr lang="de-CH"/>
           </a:p>
@@ -2134,7 +2134,7 @@
           <a:p>
             <a:fld id="{DDCE6D58-9B57-4731-A47B-3CD41B48F0A9}" type="datetimeFigureOut">
               <a:rPr lang="de-CH" smtClean="0"/>
-              <a:t>16.04.2026</a:t>
+              <a:t>13.05.2026</a:t>
             </a:fld>
             <a:endParaRPr lang="de-CH"/>
           </a:p>
@@ -2387,7 +2387,7 @@
           <a:p>
             <a:fld id="{DDCE6D58-9B57-4731-A47B-3CD41B48F0A9}" type="datetimeFigureOut">
               <a:rPr lang="de-CH" smtClean="0"/>
-              <a:t>16.04.2026</a:t>
+              <a:t>13.05.2026</a:t>
             </a:fld>
             <a:endParaRPr lang="de-CH"/>
           </a:p>
@@ -2600,7 +2600,7 @@
           <a:p>
             <a:fld id="{DDCE6D58-9B57-4731-A47B-3CD41B48F0A9}" type="datetimeFigureOut">
               <a:rPr lang="de-CH" smtClean="0"/>
-              <a:t>16.04.2026</a:t>
+              <a:t>13.05.2026</a:t>
             </a:fld>
             <a:endParaRPr lang="de-CH"/>
           </a:p>
@@ -3019,7 +3019,7 @@
         </p:nvSpPr>
         <p:spPr>
           <a:xfrm>
-            <a:off x="3327951" y="470637"/>
+            <a:off x="2591830" y="343635"/>
             <a:ext cx="1794105" cy="461665"/>
           </a:xfrm>
           <a:prstGeom prst="rect">
@@ -3072,7 +3072,7 @@
         </p:blipFill>
         <p:spPr bwMode="auto">
           <a:xfrm>
-            <a:off x="3522751" y="932302"/>
+            <a:off x="2718415" y="805300"/>
             <a:ext cx="1451034" cy="1089888"/>
           </a:xfrm>
           <a:prstGeom prst="rect">
@@ -3092,10 +3092,10 @@
       </p:pic>
       <p:sp>
         <p:nvSpPr>
-          <p:cNvPr id="3" name="Rechteck: eine Ecke abgeschnitten 2">
-            <a:extLst>
-              <a:ext uri="{FF2B5EF4-FFF2-40B4-BE49-F238E27FC236}">
-                <a16:creationId xmlns:a16="http://schemas.microsoft.com/office/drawing/2014/main" id="{3D6A2AC0-443D-170A-283D-AECFDB8A6FD0}"/>
+          <p:cNvPr id="9" name="Pfeil: nach rechts 8">
+            <a:extLst>
+              <a:ext uri="{FF2B5EF4-FFF2-40B4-BE49-F238E27FC236}">
+                <a16:creationId xmlns:a16="http://schemas.microsoft.com/office/drawing/2014/main" id="{480CCF0E-2FDE-7E06-5542-D3E439FE72AD}"/>
               </a:ext>
             </a:extLst>
           </p:cNvPr>
@@ -3104,98 +3104,7 @@
         </p:nvSpPr>
         <p:spPr>
           <a:xfrm>
-            <a:off x="1433950" y="602669"/>
-            <a:ext cx="1069163" cy="1419521"/>
-          </a:xfrm>
-          <a:prstGeom prst="snip1Rect">
-            <a:avLst/>
-          </a:prstGeom>
-          <a:noFill/>
-          <a:ln>
-            <a:solidFill>
-              <a:schemeClr val="tx1"/>
-            </a:solidFill>
-          </a:ln>
-        </p:spPr>
-        <p:style>
-          <a:lnRef idx="2">
-            <a:schemeClr val="accent1">
-              <a:shade val="15000"/>
-            </a:schemeClr>
-          </a:lnRef>
-          <a:fillRef idx="1">
-            <a:schemeClr val="accent1"/>
-          </a:fillRef>
-          <a:effectRef idx="0">
-            <a:schemeClr val="accent1"/>
-          </a:effectRef>
-          <a:fontRef idx="minor">
-            <a:schemeClr val="lt1"/>
-          </a:fontRef>
-        </p:style>
-        <p:txBody>
-          <a:bodyPr rtlCol="0" anchor="ctr"/>
-          <a:lstStyle/>
-          <a:p>
-            <a:pPr algn="ctr"/>
-            <a:endParaRPr lang="de-CH" b="1" dirty="0">
-              <a:solidFill>
-                <a:schemeClr val="tx1"/>
-              </a:solidFill>
-              <a:latin typeface="Arial" panose="020B0604020202020204" pitchFamily="34" charset="0"/>
-              <a:cs typeface="Arial" panose="020B0604020202020204" pitchFamily="34" charset="0"/>
-            </a:endParaRPr>
-          </a:p>
-          <a:p>
-            <a:pPr algn="ctr"/>
-            <a:r>
-              <a:rPr lang="de-CH" b="1" dirty="0">
-                <a:solidFill>
-                  <a:schemeClr val="tx1"/>
-                </a:solidFill>
-                <a:latin typeface="Arial" panose="020B0604020202020204" pitchFamily="34" charset="0"/>
-                <a:cs typeface="Arial" panose="020B0604020202020204" pitchFamily="34" charset="0"/>
-              </a:rPr>
-              <a:t>Layout XML Datei</a:t>
-            </a:r>
-          </a:p>
-          <a:p>
-            <a:pPr algn="ctr"/>
-            <a:endParaRPr lang="de-CH" b="1" dirty="0">
-              <a:solidFill>
-                <a:schemeClr val="tx1"/>
-              </a:solidFill>
-              <a:latin typeface="Arial" panose="020B0604020202020204" pitchFamily="34" charset="0"/>
-              <a:cs typeface="Arial" panose="020B0604020202020204" pitchFamily="34" charset="0"/>
-            </a:endParaRPr>
-          </a:p>
-          <a:p>
-            <a:pPr algn="ctr"/>
-            <a:endParaRPr lang="de-CH" b="1" dirty="0">
-              <a:solidFill>
-                <a:schemeClr val="tx1"/>
-              </a:solidFill>
-              <a:latin typeface="Arial" panose="020B0604020202020204" pitchFamily="34" charset="0"/>
-              <a:cs typeface="Arial" panose="020B0604020202020204" pitchFamily="34" charset="0"/>
-            </a:endParaRPr>
-          </a:p>
-        </p:txBody>
-      </p:sp>
-      <p:sp>
-        <p:nvSpPr>
-          <p:cNvPr id="4" name="Pfeil: nach rechts 3">
-            <a:extLst>
-              <a:ext uri="{FF2B5EF4-FFF2-40B4-BE49-F238E27FC236}">
-                <a16:creationId xmlns:a16="http://schemas.microsoft.com/office/drawing/2014/main" id="{E63618D3-7625-E875-5354-769B8EBB1179}"/>
-              </a:ext>
-            </a:extLst>
-          </p:cNvPr>
-          <p:cNvSpPr/>
-          <p:nvPr/>
-        </p:nvSpPr>
-        <p:spPr>
-          <a:xfrm>
-            <a:off x="2739781" y="1204609"/>
+            <a:off x="5108436" y="1204609"/>
             <a:ext cx="623944" cy="365760"/>
           </a:xfrm>
           <a:prstGeom prst="rightArrow">
@@ -3235,10 +3144,10 @@
       </p:sp>
       <p:sp>
         <p:nvSpPr>
-          <p:cNvPr id="9" name="Pfeil: nach rechts 8">
-            <a:extLst>
-              <a:ext uri="{FF2B5EF4-FFF2-40B4-BE49-F238E27FC236}">
-                <a16:creationId xmlns:a16="http://schemas.microsoft.com/office/drawing/2014/main" id="{480CCF0E-2FDE-7E06-5542-D3E439FE72AD}"/>
+          <p:cNvPr id="16" name="Pfeil: nach rechts 15">
+            <a:extLst>
+              <a:ext uri="{FF2B5EF4-FFF2-40B4-BE49-F238E27FC236}">
+                <a16:creationId xmlns:a16="http://schemas.microsoft.com/office/drawing/2014/main" id="{DE1E6BDE-0D3B-2B1B-A574-DFE72FA02B2A}"/>
               </a:ext>
             </a:extLst>
           </p:cNvPr>
@@ -3247,7 +3156,7 @@
         </p:nvSpPr>
         <p:spPr>
           <a:xfrm>
-            <a:off x="5108436" y="1204609"/>
+            <a:off x="1433950" y="3772937"/>
             <a:ext cx="623944" cy="365760"/>
           </a:xfrm>
           <a:prstGeom prst="rightArrow">
@@ -3287,10 +3196,10 @@
       </p:sp>
       <p:pic>
         <p:nvPicPr>
-          <p:cNvPr id="15" name="Grafik 14">
-            <a:extLst>
-              <a:ext uri="{FF2B5EF4-FFF2-40B4-BE49-F238E27FC236}">
-                <a16:creationId xmlns:a16="http://schemas.microsoft.com/office/drawing/2014/main" id="{A859E9C5-B61C-3491-0DB9-2B59D4EE00B9}"/>
+          <p:cNvPr id="24" name="Grafik 23">
+            <a:extLst>
+              <a:ext uri="{FF2B5EF4-FFF2-40B4-BE49-F238E27FC236}">
+                <a16:creationId xmlns:a16="http://schemas.microsoft.com/office/drawing/2014/main" id="{4222F74F-8BB1-23C9-C225-4B7D8D550919}"/>
               </a:ext>
             </a:extLst>
           </p:cNvPr>
@@ -3307,72 +3216,20 @@
         </p:blipFill>
         <p:spPr>
           <a:xfrm>
-            <a:off x="5946894" y="339316"/>
-            <a:ext cx="2043715" cy="2144108"/>
+            <a:off x="5836916" y="2783806"/>
+            <a:ext cx="2263669" cy="2144109"/>
           </a:xfrm>
           <a:prstGeom prst="rect">
             <a:avLst/>
           </a:prstGeom>
         </p:spPr>
       </p:pic>
-      <p:sp>
-        <p:nvSpPr>
-          <p:cNvPr id="16" name="Pfeil: nach rechts 15">
-            <a:extLst>
-              <a:ext uri="{FF2B5EF4-FFF2-40B4-BE49-F238E27FC236}">
-                <a16:creationId xmlns:a16="http://schemas.microsoft.com/office/drawing/2014/main" id="{DE1E6BDE-0D3B-2B1B-A574-DFE72FA02B2A}"/>
-              </a:ext>
-            </a:extLst>
-          </p:cNvPr>
-          <p:cNvSpPr/>
-          <p:nvPr/>
-        </p:nvSpPr>
-        <p:spPr>
-          <a:xfrm>
-            <a:off x="1433950" y="3518933"/>
-            <a:ext cx="623944" cy="365760"/>
-          </a:xfrm>
-          <a:prstGeom prst="rightArrow">
-            <a:avLst/>
-          </a:prstGeom>
-          <a:noFill/>
-          <a:ln w="28575">
-            <a:solidFill>
-              <a:schemeClr val="tx1"/>
-            </a:solidFill>
-          </a:ln>
-        </p:spPr>
-        <p:style>
-          <a:lnRef idx="2">
-            <a:schemeClr val="accent1">
-              <a:shade val="15000"/>
-            </a:schemeClr>
-          </a:lnRef>
-          <a:fillRef idx="1">
-            <a:schemeClr val="accent1"/>
-          </a:fillRef>
-          <a:effectRef idx="0">
-            <a:schemeClr val="accent1"/>
-          </a:effectRef>
-          <a:fontRef idx="minor">
-            <a:schemeClr val="lt1"/>
-          </a:fontRef>
-        </p:style>
-        <p:txBody>
-          <a:bodyPr rtlCol="0" anchor="ctr"/>
-          <a:lstStyle/>
-          <a:p>
-            <a:pPr algn="ctr"/>
-            <a:endParaRPr lang="de-CH"/>
-          </a:p>
-        </p:txBody>
-      </p:sp>
       <p:pic>
         <p:nvPicPr>
-          <p:cNvPr id="24" name="Grafik 23">
-            <a:extLst>
-              <a:ext uri="{FF2B5EF4-FFF2-40B4-BE49-F238E27FC236}">
-                <a16:creationId xmlns:a16="http://schemas.microsoft.com/office/drawing/2014/main" id="{4222F74F-8BB1-23C9-C225-4B7D8D550919}"/>
+          <p:cNvPr id="26" name="Grafik 25">
+            <a:extLst>
+              <a:ext uri="{FF2B5EF4-FFF2-40B4-BE49-F238E27FC236}">
+                <a16:creationId xmlns:a16="http://schemas.microsoft.com/office/drawing/2014/main" id="{CED8465B-4685-75F9-40F6-8E1FDD0D6B4E}"/>
               </a:ext>
             </a:extLst>
           </p:cNvPr>
@@ -3389,20 +3246,72 @@
         </p:blipFill>
         <p:spPr>
           <a:xfrm>
-            <a:off x="5836916" y="2529802"/>
-            <a:ext cx="2263669" cy="2144109"/>
+            <a:off x="2286673" y="3068935"/>
+            <a:ext cx="2154103" cy="1697852"/>
           </a:xfrm>
           <a:prstGeom prst="rect">
             <a:avLst/>
           </a:prstGeom>
         </p:spPr>
       </p:pic>
+      <p:sp>
+        <p:nvSpPr>
+          <p:cNvPr id="27" name="Pfeil: nach rechts 26">
+            <a:extLst>
+              <a:ext uri="{FF2B5EF4-FFF2-40B4-BE49-F238E27FC236}">
+                <a16:creationId xmlns:a16="http://schemas.microsoft.com/office/drawing/2014/main" id="{70486B96-89EB-ABE2-394C-7065D1E6F563}"/>
+              </a:ext>
+            </a:extLst>
+          </p:cNvPr>
+          <p:cNvSpPr/>
+          <p:nvPr/>
+        </p:nvSpPr>
+        <p:spPr>
+          <a:xfrm>
+            <a:off x="5108436" y="3772937"/>
+            <a:ext cx="623944" cy="365760"/>
+          </a:xfrm>
+          <a:prstGeom prst="rightArrow">
+            <a:avLst/>
+          </a:prstGeom>
+          <a:noFill/>
+          <a:ln w="28575">
+            <a:solidFill>
+              <a:schemeClr val="tx1"/>
+            </a:solidFill>
+          </a:ln>
+        </p:spPr>
+        <p:style>
+          <a:lnRef idx="2">
+            <a:schemeClr val="accent1">
+              <a:shade val="15000"/>
+            </a:schemeClr>
+          </a:lnRef>
+          <a:fillRef idx="1">
+            <a:schemeClr val="accent1"/>
+          </a:fillRef>
+          <a:effectRef idx="0">
+            <a:schemeClr val="accent1"/>
+          </a:effectRef>
+          <a:fontRef idx="minor">
+            <a:schemeClr val="lt1"/>
+          </a:fontRef>
+        </p:style>
+        <p:txBody>
+          <a:bodyPr rtlCol="0" anchor="ctr"/>
+          <a:lstStyle/>
+          <a:p>
+            <a:pPr algn="ctr"/>
+            <a:endParaRPr lang="de-CH"/>
+          </a:p>
+        </p:txBody>
+      </p:sp>
       <p:pic>
         <p:nvPicPr>
-          <p:cNvPr id="26" name="Grafik 25">
-            <a:extLst>
-              <a:ext uri="{FF2B5EF4-FFF2-40B4-BE49-F238E27FC236}">
-                <a16:creationId xmlns:a16="http://schemas.microsoft.com/office/drawing/2014/main" id="{CED8465B-4685-75F9-40F6-8E1FDD0D6B4E}"/>
+          <p:cNvPr id="31" name="Grafik 30">
+            <a:extLst>
+              <a:ext uri="{FF2B5EF4-FFF2-40B4-BE49-F238E27FC236}">
+                <a16:creationId xmlns:a16="http://schemas.microsoft.com/office/drawing/2014/main" id="{47FD86A1-E985-C066-2FEA-B4B779C500E1}"/>
               </a:ext>
             </a:extLst>
           </p:cNvPr>
@@ -3419,8 +3328,8 @@
         </p:blipFill>
         <p:spPr>
           <a:xfrm>
-            <a:off x="2286673" y="2814931"/>
-            <a:ext cx="2154103" cy="1697852"/>
+            <a:off x="2286673" y="5036500"/>
+            <a:ext cx="2209848" cy="1741790"/>
           </a:xfrm>
           <a:prstGeom prst="rect">
             <a:avLst/>
@@ -3429,10 +3338,10 @@
       </p:pic>
       <p:sp>
         <p:nvSpPr>
-          <p:cNvPr id="27" name="Pfeil: nach rechts 26">
-            <a:extLst>
-              <a:ext uri="{FF2B5EF4-FFF2-40B4-BE49-F238E27FC236}">
-                <a16:creationId xmlns:a16="http://schemas.microsoft.com/office/drawing/2014/main" id="{70486B96-89EB-ABE2-394C-7065D1E6F563}"/>
+          <p:cNvPr id="32" name="Pfeil: nach rechts 31">
+            <a:extLst>
+              <a:ext uri="{FF2B5EF4-FFF2-40B4-BE49-F238E27FC236}">
+                <a16:creationId xmlns:a16="http://schemas.microsoft.com/office/drawing/2014/main" id="{508059D0-DBD9-CD0F-458A-0290073AFF3C}"/>
               </a:ext>
             </a:extLst>
           </p:cNvPr>
@@ -3441,7 +3350,7 @@
         </p:nvSpPr>
         <p:spPr>
           <a:xfrm>
-            <a:off x="5108436" y="3518933"/>
+            <a:off x="1475763" y="5724515"/>
             <a:ext cx="623944" cy="365760"/>
           </a:xfrm>
           <a:prstGeom prst="rightArrow">
@@ -3479,12 +3388,64 @@
           </a:p>
         </p:txBody>
       </p:sp>
+      <p:sp>
+        <p:nvSpPr>
+          <p:cNvPr id="35" name="Pfeil: nach rechts 34">
+            <a:extLst>
+              <a:ext uri="{FF2B5EF4-FFF2-40B4-BE49-F238E27FC236}">
+                <a16:creationId xmlns:a16="http://schemas.microsoft.com/office/drawing/2014/main" id="{E3622591-324C-8565-8509-79D0977A44A3}"/>
+              </a:ext>
+            </a:extLst>
+          </p:cNvPr>
+          <p:cNvSpPr/>
+          <p:nvPr/>
+        </p:nvSpPr>
+        <p:spPr>
+          <a:xfrm>
+            <a:off x="5185524" y="5641974"/>
+            <a:ext cx="623944" cy="365760"/>
+          </a:xfrm>
+          <a:prstGeom prst="rightArrow">
+            <a:avLst/>
+          </a:prstGeom>
+          <a:noFill/>
+          <a:ln w="28575">
+            <a:solidFill>
+              <a:schemeClr val="tx1"/>
+            </a:solidFill>
+          </a:ln>
+        </p:spPr>
+        <p:style>
+          <a:lnRef idx="2">
+            <a:schemeClr val="accent1">
+              <a:shade val="15000"/>
+            </a:schemeClr>
+          </a:lnRef>
+          <a:fillRef idx="1">
+            <a:schemeClr val="accent1"/>
+          </a:fillRef>
+          <a:effectRef idx="0">
+            <a:schemeClr val="accent1"/>
+          </a:effectRef>
+          <a:fontRef idx="minor">
+            <a:schemeClr val="lt1"/>
+          </a:fontRef>
+        </p:style>
+        <p:txBody>
+          <a:bodyPr rtlCol="0" anchor="ctr"/>
+          <a:lstStyle/>
+          <a:p>
+            <a:pPr algn="ctr"/>
+            <a:endParaRPr lang="de-CH"/>
+          </a:p>
+        </p:txBody>
+      </p:sp>
       <p:pic>
         <p:nvPicPr>
-          <p:cNvPr id="31" name="Grafik 30">
-            <a:extLst>
-              <a:ext uri="{FF2B5EF4-FFF2-40B4-BE49-F238E27FC236}">
-                <a16:creationId xmlns:a16="http://schemas.microsoft.com/office/drawing/2014/main" id="{47FD86A1-E985-C066-2FEA-B4B779C500E1}"/>
+          <p:cNvPr id="37" name="Grafik 36">
+            <a:extLst>
+              <a:ext uri="{FF2B5EF4-FFF2-40B4-BE49-F238E27FC236}">
+                <a16:creationId xmlns:a16="http://schemas.microsoft.com/office/drawing/2014/main" id="{47F77300-43CE-FA5B-A117-F828858A0544}"/>
               </a:ext>
             </a:extLst>
           </p:cNvPr>
@@ -3501,124 +3462,20 @@
         </p:blipFill>
         <p:spPr>
           <a:xfrm>
-            <a:off x="2286673" y="4782496"/>
-            <a:ext cx="2209848" cy="1741790"/>
+            <a:off x="5955531" y="5092718"/>
+            <a:ext cx="892078" cy="1701990"/>
           </a:xfrm>
           <a:prstGeom prst="rect">
             <a:avLst/>
           </a:prstGeom>
         </p:spPr>
       </p:pic>
-      <p:sp>
-        <p:nvSpPr>
-          <p:cNvPr id="32" name="Pfeil: nach rechts 31">
-            <a:extLst>
-              <a:ext uri="{FF2B5EF4-FFF2-40B4-BE49-F238E27FC236}">
-                <a16:creationId xmlns:a16="http://schemas.microsoft.com/office/drawing/2014/main" id="{508059D0-DBD9-CD0F-458A-0290073AFF3C}"/>
-              </a:ext>
-            </a:extLst>
-          </p:cNvPr>
-          <p:cNvSpPr/>
-          <p:nvPr/>
-        </p:nvSpPr>
-        <p:spPr>
-          <a:xfrm>
-            <a:off x="1475763" y="5470511"/>
-            <a:ext cx="623944" cy="365760"/>
-          </a:xfrm>
-          <a:prstGeom prst="rightArrow">
-            <a:avLst/>
-          </a:prstGeom>
-          <a:noFill/>
-          <a:ln w="28575">
-            <a:solidFill>
-              <a:schemeClr val="tx1"/>
-            </a:solidFill>
-          </a:ln>
-        </p:spPr>
-        <p:style>
-          <a:lnRef idx="2">
-            <a:schemeClr val="accent1">
-              <a:shade val="15000"/>
-            </a:schemeClr>
-          </a:lnRef>
-          <a:fillRef idx="1">
-            <a:schemeClr val="accent1"/>
-          </a:fillRef>
-          <a:effectRef idx="0">
-            <a:schemeClr val="accent1"/>
-          </a:effectRef>
-          <a:fontRef idx="minor">
-            <a:schemeClr val="lt1"/>
-          </a:fontRef>
-        </p:style>
-        <p:txBody>
-          <a:bodyPr rtlCol="0" anchor="ctr"/>
-          <a:lstStyle/>
-          <a:p>
-            <a:pPr algn="ctr"/>
-            <a:endParaRPr lang="de-CH"/>
-          </a:p>
-        </p:txBody>
-      </p:sp>
-      <p:sp>
-        <p:nvSpPr>
-          <p:cNvPr id="35" name="Pfeil: nach rechts 34">
-            <a:extLst>
-              <a:ext uri="{FF2B5EF4-FFF2-40B4-BE49-F238E27FC236}">
-                <a16:creationId xmlns:a16="http://schemas.microsoft.com/office/drawing/2014/main" id="{E3622591-324C-8565-8509-79D0977A44A3}"/>
-              </a:ext>
-            </a:extLst>
-          </p:cNvPr>
-          <p:cNvSpPr/>
-          <p:nvPr/>
-        </p:nvSpPr>
-        <p:spPr>
-          <a:xfrm>
-            <a:off x="5185524" y="5387970"/>
-            <a:ext cx="623944" cy="365760"/>
-          </a:xfrm>
-          <a:prstGeom prst="rightArrow">
-            <a:avLst/>
-          </a:prstGeom>
-          <a:noFill/>
-          <a:ln w="28575">
-            <a:solidFill>
-              <a:schemeClr val="tx1"/>
-            </a:solidFill>
-          </a:ln>
-        </p:spPr>
-        <p:style>
-          <a:lnRef idx="2">
-            <a:schemeClr val="accent1">
-              <a:shade val="15000"/>
-            </a:schemeClr>
-          </a:lnRef>
-          <a:fillRef idx="1">
-            <a:schemeClr val="accent1"/>
-          </a:fillRef>
-          <a:effectRef idx="0">
-            <a:schemeClr val="accent1"/>
-          </a:effectRef>
-          <a:fontRef idx="minor">
-            <a:schemeClr val="lt1"/>
-          </a:fontRef>
-        </p:style>
-        <p:txBody>
-          <a:bodyPr rtlCol="0" anchor="ctr"/>
-          <a:lstStyle/>
-          <a:p>
-            <a:pPr algn="ctr"/>
-            <a:endParaRPr lang="de-CH"/>
-          </a:p>
-        </p:txBody>
-      </p:sp>
       <p:pic>
         <p:nvPicPr>
-          <p:cNvPr id="37" name="Grafik 36">
-            <a:extLst>
-              <a:ext uri="{FF2B5EF4-FFF2-40B4-BE49-F238E27FC236}">
-                <a16:creationId xmlns:a16="http://schemas.microsoft.com/office/drawing/2014/main" id="{47F77300-43CE-FA5B-A117-F828858A0544}"/>
+          <p:cNvPr id="39" name="Grafik 38">
+            <a:extLst>
+              <a:ext uri="{FF2B5EF4-FFF2-40B4-BE49-F238E27FC236}">
+                <a16:creationId xmlns:a16="http://schemas.microsoft.com/office/drawing/2014/main" id="{2AFCC7E1-DC5E-D9CF-D417-6494C4C5C88F}"/>
               </a:ext>
             </a:extLst>
           </p:cNvPr>
@@ -3635,8 +3492,8 @@
         </p:blipFill>
         <p:spPr>
           <a:xfrm>
-            <a:off x="5955531" y="4838714"/>
-            <a:ext cx="892078" cy="1701990"/>
+            <a:off x="7014454" y="5247473"/>
+            <a:ext cx="1141481" cy="1520522"/>
           </a:xfrm>
           <a:prstGeom prst="rect">
             <a:avLst/>
@@ -3645,10 +3502,10 @@
       </p:pic>
       <p:pic>
         <p:nvPicPr>
-          <p:cNvPr id="39" name="Grafik 38">
-            <a:extLst>
-              <a:ext uri="{FF2B5EF4-FFF2-40B4-BE49-F238E27FC236}">
-                <a16:creationId xmlns:a16="http://schemas.microsoft.com/office/drawing/2014/main" id="{2AFCC7E1-DC5E-D9CF-D417-6494C4C5C88F}"/>
+          <p:cNvPr id="7" name="Grafik 6">
+            <a:extLst>
+              <a:ext uri="{FF2B5EF4-FFF2-40B4-BE49-F238E27FC236}">
+                <a16:creationId xmlns:a16="http://schemas.microsoft.com/office/drawing/2014/main" id="{7FB7A527-BBCE-7268-D0E7-ED24CA079D41}"/>
               </a:ext>
             </a:extLst>
           </p:cNvPr>
@@ -3665,8 +3522,142 @@
         </p:blipFill>
         <p:spPr>
           <a:xfrm>
-            <a:off x="7014454" y="4993469"/>
-            <a:ext cx="1141481" cy="1520522"/>
+            <a:off x="5946894" y="344238"/>
+            <a:ext cx="2084960" cy="2430057"/>
+          </a:xfrm>
+          <a:prstGeom prst="rect">
+            <a:avLst/>
+          </a:prstGeom>
+        </p:spPr>
+      </p:pic>
+      <p:sp>
+        <p:nvSpPr>
+          <p:cNvPr id="13" name="Pfeil: nach rechts 12">
+            <a:extLst>
+              <a:ext uri="{FF2B5EF4-FFF2-40B4-BE49-F238E27FC236}">
+                <a16:creationId xmlns:a16="http://schemas.microsoft.com/office/drawing/2014/main" id="{0D71785A-E476-C521-3A2A-84F41E20CD40}"/>
+              </a:ext>
+            </a:extLst>
+          </p:cNvPr>
+          <p:cNvSpPr/>
+          <p:nvPr/>
+        </p:nvSpPr>
+        <p:spPr>
+          <a:xfrm>
+            <a:off x="1433950" y="2431114"/>
+            <a:ext cx="623944" cy="365760"/>
+          </a:xfrm>
+          <a:prstGeom prst="rightArrow">
+            <a:avLst/>
+          </a:prstGeom>
+          <a:noFill/>
+          <a:ln w="28575">
+            <a:solidFill>
+              <a:schemeClr val="tx1"/>
+            </a:solidFill>
+          </a:ln>
+        </p:spPr>
+        <p:style>
+          <a:lnRef idx="2">
+            <a:schemeClr val="accent1">
+              <a:shade val="15000"/>
+            </a:schemeClr>
+          </a:lnRef>
+          <a:fillRef idx="1">
+            <a:schemeClr val="accent1"/>
+          </a:fillRef>
+          <a:effectRef idx="0">
+            <a:schemeClr val="accent1"/>
+          </a:effectRef>
+          <a:fontRef idx="minor">
+            <a:schemeClr val="lt1"/>
+          </a:fontRef>
+        </p:style>
+        <p:txBody>
+          <a:bodyPr rtlCol="0" anchor="ctr"/>
+          <a:lstStyle/>
+          <a:p>
+            <a:pPr algn="ctr"/>
+            <a:endParaRPr lang="de-CH"/>
+          </a:p>
+        </p:txBody>
+      </p:sp>
+      <p:sp>
+        <p:nvSpPr>
+          <p:cNvPr id="14" name="Pfeil: nach rechts 13">
+            <a:extLst>
+              <a:ext uri="{FF2B5EF4-FFF2-40B4-BE49-F238E27FC236}">
+                <a16:creationId xmlns:a16="http://schemas.microsoft.com/office/drawing/2014/main" id="{6441599B-1695-B7BB-1063-A2324A3D8DB5}"/>
+              </a:ext>
+            </a:extLst>
+          </p:cNvPr>
+          <p:cNvSpPr/>
+          <p:nvPr/>
+        </p:nvSpPr>
+        <p:spPr>
+          <a:xfrm>
+            <a:off x="5122056" y="2378842"/>
+            <a:ext cx="623944" cy="365760"/>
+          </a:xfrm>
+          <a:prstGeom prst="rightArrow">
+            <a:avLst/>
+          </a:prstGeom>
+          <a:noFill/>
+          <a:ln w="28575">
+            <a:solidFill>
+              <a:schemeClr val="tx1"/>
+            </a:solidFill>
+          </a:ln>
+        </p:spPr>
+        <p:style>
+          <a:lnRef idx="2">
+            <a:schemeClr val="accent1">
+              <a:shade val="15000"/>
+            </a:schemeClr>
+          </a:lnRef>
+          <a:fillRef idx="1">
+            <a:schemeClr val="accent1"/>
+          </a:fillRef>
+          <a:effectRef idx="0">
+            <a:schemeClr val="accent1"/>
+          </a:effectRef>
+          <a:fontRef idx="minor">
+            <a:schemeClr val="lt1"/>
+          </a:fontRef>
+        </p:style>
+        <p:txBody>
+          <a:bodyPr rtlCol="0" anchor="ctr"/>
+          <a:lstStyle/>
+          <a:p>
+            <a:pPr algn="ctr"/>
+            <a:endParaRPr lang="de-CH"/>
+          </a:p>
+        </p:txBody>
+      </p:sp>
+      <p:pic>
+        <p:nvPicPr>
+          <p:cNvPr id="18" name="Grafik 17">
+            <a:extLst>
+              <a:ext uri="{FF2B5EF4-FFF2-40B4-BE49-F238E27FC236}">
+                <a16:creationId xmlns:a16="http://schemas.microsoft.com/office/drawing/2014/main" id="{BD17F727-2BB5-1967-B3CF-413D6D9A8D0D}"/>
+              </a:ext>
+            </a:extLst>
+          </p:cNvPr>
+          <p:cNvPicPr>
+            <a:picLocks noChangeAspect="1"/>
+          </p:cNvPicPr>
+          <p:nvPr/>
+        </p:nvPicPr>
+        <p:blipFill>
+          <a:blip r:embed="rId9"/>
+          <a:stretch>
+            <a:fillRect/>
+          </a:stretch>
+        </p:blipFill>
+        <p:spPr>
+          <a:xfrm>
+            <a:off x="2274834" y="1979047"/>
+            <a:ext cx="2537683" cy="1037199"/>
           </a:xfrm>
           <a:prstGeom prst="rect">
             <a:avLst/>

</xml_diff>